<commit_message>
Mise à jour des règles avec Hérauts de Pourparlers - en français
</commit_message>
<xml_diff>
--- a/pictures/Memos/memo-fr.pptx
+++ b/pictures/Memos/memo-fr.pptx
@@ -197,7 +197,7 @@
           <a:p>
             <a:fld id="{849D895D-661B-479D-A688-27E503324CF6}" type="datetimeFigureOut">
               <a:rPr lang="fr-FR" smtClean="0"/>
-              <a:t>27/04/2026</a:t>
+              <a:t>15/05/2026</a:t>
             </a:fld>
             <a:endParaRPr lang="fr-FR"/>
           </a:p>
@@ -679,7 +679,7 @@
           <a:p>
             <a:fld id="{017B969D-5DBB-4D98-A8ED-E39D79CDECF7}" type="datetimeFigureOut">
               <a:rPr lang="fr-FR" smtClean="0"/>
-              <a:t>27/04/2026</a:t>
+              <a:t>15/05/2026</a:t>
             </a:fld>
             <a:endParaRPr lang="fr-FR"/>
           </a:p>
@@ -849,7 +849,7 @@
           <a:p>
             <a:fld id="{017B969D-5DBB-4D98-A8ED-E39D79CDECF7}" type="datetimeFigureOut">
               <a:rPr lang="fr-FR" smtClean="0"/>
-              <a:t>27/04/2026</a:t>
+              <a:t>15/05/2026</a:t>
             </a:fld>
             <a:endParaRPr lang="fr-FR"/>
           </a:p>
@@ -1029,7 +1029,7 @@
           <a:p>
             <a:fld id="{017B969D-5DBB-4D98-A8ED-E39D79CDECF7}" type="datetimeFigureOut">
               <a:rPr lang="fr-FR" smtClean="0"/>
-              <a:t>27/04/2026</a:t>
+              <a:t>15/05/2026</a:t>
             </a:fld>
             <a:endParaRPr lang="fr-FR"/>
           </a:p>
@@ -1199,7 +1199,7 @@
           <a:p>
             <a:fld id="{017B969D-5DBB-4D98-A8ED-E39D79CDECF7}" type="datetimeFigureOut">
               <a:rPr lang="fr-FR" smtClean="0"/>
-              <a:t>27/04/2026</a:t>
+              <a:t>15/05/2026</a:t>
             </a:fld>
             <a:endParaRPr lang="fr-FR"/>
           </a:p>
@@ -1445,7 +1445,7 @@
           <a:p>
             <a:fld id="{017B969D-5DBB-4D98-A8ED-E39D79CDECF7}" type="datetimeFigureOut">
               <a:rPr lang="fr-FR" smtClean="0"/>
-              <a:t>27/04/2026</a:t>
+              <a:t>15/05/2026</a:t>
             </a:fld>
             <a:endParaRPr lang="fr-FR"/>
           </a:p>
@@ -1677,7 +1677,7 @@
           <a:p>
             <a:fld id="{017B969D-5DBB-4D98-A8ED-E39D79CDECF7}" type="datetimeFigureOut">
               <a:rPr lang="fr-FR" smtClean="0"/>
-              <a:t>27/04/2026</a:t>
+              <a:t>15/05/2026</a:t>
             </a:fld>
             <a:endParaRPr lang="fr-FR"/>
           </a:p>
@@ -2044,7 +2044,7 @@
           <a:p>
             <a:fld id="{017B969D-5DBB-4D98-A8ED-E39D79CDECF7}" type="datetimeFigureOut">
               <a:rPr lang="fr-FR" smtClean="0"/>
-              <a:t>27/04/2026</a:t>
+              <a:t>15/05/2026</a:t>
             </a:fld>
             <a:endParaRPr lang="fr-FR"/>
           </a:p>
@@ -2162,7 +2162,7 @@
           <a:p>
             <a:fld id="{017B969D-5DBB-4D98-A8ED-E39D79CDECF7}" type="datetimeFigureOut">
               <a:rPr lang="fr-FR" smtClean="0"/>
-              <a:t>27/04/2026</a:t>
+              <a:t>15/05/2026</a:t>
             </a:fld>
             <a:endParaRPr lang="fr-FR"/>
           </a:p>
@@ -2257,7 +2257,7 @@
           <a:p>
             <a:fld id="{017B969D-5DBB-4D98-A8ED-E39D79CDECF7}" type="datetimeFigureOut">
               <a:rPr lang="fr-FR" smtClean="0"/>
-              <a:t>27/04/2026</a:t>
+              <a:t>15/05/2026</a:t>
             </a:fld>
             <a:endParaRPr lang="fr-FR"/>
           </a:p>
@@ -2534,7 +2534,7 @@
           <a:p>
             <a:fld id="{017B969D-5DBB-4D98-A8ED-E39D79CDECF7}" type="datetimeFigureOut">
               <a:rPr lang="fr-FR" smtClean="0"/>
-              <a:t>27/04/2026</a:t>
+              <a:t>15/05/2026</a:t>
             </a:fld>
             <a:endParaRPr lang="fr-FR"/>
           </a:p>
@@ -2791,7 +2791,7 @@
           <a:p>
             <a:fld id="{017B969D-5DBB-4D98-A8ED-E39D79CDECF7}" type="datetimeFigureOut">
               <a:rPr lang="fr-FR" smtClean="0"/>
-              <a:t>27/04/2026</a:t>
+              <a:t>15/05/2026</a:t>
             </a:fld>
             <a:endParaRPr lang="fr-FR"/>
           </a:p>
@@ -3004,7 +3004,7 @@
           <a:p>
             <a:fld id="{017B969D-5DBB-4D98-A8ED-E39D79CDECF7}" type="datetimeFigureOut">
               <a:rPr lang="fr-FR" smtClean="0"/>
-              <a:t>27/04/2026</a:t>
+              <a:t>15/05/2026</a:t>
             </a:fld>
             <a:endParaRPr lang="fr-FR"/>
           </a:p>
@@ -3954,9 +3954,12 @@
               <a:rPr lang="fr-FR" sz="1117" dirty="0">
                 <a:sym typeface="Wingdings" panose="05000000000000000000" pitchFamily="2" charset="2"/>
               </a:rPr>
-              <a:t> Résoudre la Calamité</a:t>
-            </a:r>
-            <a:endParaRPr lang="fr-FR" sz="1117" dirty="0"/>
+              <a:t> Résoudre E</a:t>
+            </a:r>
+            <a:r>
+              <a:rPr lang="fr-FR" sz="1117" dirty="0"/>
+              <a:t>vénement</a:t>
+            </a:r>
           </a:p>
         </p:txBody>
       </p:sp>

</xml_diff>

<commit_message>
Première réécriture avec Espion et nouveau second deck
</commit_message>
<xml_diff>
--- a/pictures/Memos/memo-fr.pptx
+++ b/pictures/Memos/memo-fr.pptx
@@ -197,7 +197,7 @@
           <a:p>
             <a:fld id="{849D895D-661B-479D-A688-27E503324CF6}" type="datetimeFigureOut">
               <a:rPr lang="fr-FR" smtClean="0"/>
-              <a:t>15/05/2026</a:t>
+              <a:t>25/05/2026</a:t>
             </a:fld>
             <a:endParaRPr lang="fr-FR"/>
           </a:p>
@@ -679,7 +679,7 @@
           <a:p>
             <a:fld id="{017B969D-5DBB-4D98-A8ED-E39D79CDECF7}" type="datetimeFigureOut">
               <a:rPr lang="fr-FR" smtClean="0"/>
-              <a:t>15/05/2026</a:t>
+              <a:t>25/05/2026</a:t>
             </a:fld>
             <a:endParaRPr lang="fr-FR"/>
           </a:p>
@@ -849,7 +849,7 @@
           <a:p>
             <a:fld id="{017B969D-5DBB-4D98-A8ED-E39D79CDECF7}" type="datetimeFigureOut">
               <a:rPr lang="fr-FR" smtClean="0"/>
-              <a:t>15/05/2026</a:t>
+              <a:t>25/05/2026</a:t>
             </a:fld>
             <a:endParaRPr lang="fr-FR"/>
           </a:p>
@@ -1029,7 +1029,7 @@
           <a:p>
             <a:fld id="{017B969D-5DBB-4D98-A8ED-E39D79CDECF7}" type="datetimeFigureOut">
               <a:rPr lang="fr-FR" smtClean="0"/>
-              <a:t>15/05/2026</a:t>
+              <a:t>25/05/2026</a:t>
             </a:fld>
             <a:endParaRPr lang="fr-FR"/>
           </a:p>
@@ -1199,7 +1199,7 @@
           <a:p>
             <a:fld id="{017B969D-5DBB-4D98-A8ED-E39D79CDECF7}" type="datetimeFigureOut">
               <a:rPr lang="fr-FR" smtClean="0"/>
-              <a:t>15/05/2026</a:t>
+              <a:t>25/05/2026</a:t>
             </a:fld>
             <a:endParaRPr lang="fr-FR"/>
           </a:p>
@@ -1445,7 +1445,7 @@
           <a:p>
             <a:fld id="{017B969D-5DBB-4D98-A8ED-E39D79CDECF7}" type="datetimeFigureOut">
               <a:rPr lang="fr-FR" smtClean="0"/>
-              <a:t>15/05/2026</a:t>
+              <a:t>25/05/2026</a:t>
             </a:fld>
             <a:endParaRPr lang="fr-FR"/>
           </a:p>
@@ -1677,7 +1677,7 @@
           <a:p>
             <a:fld id="{017B969D-5DBB-4D98-A8ED-E39D79CDECF7}" type="datetimeFigureOut">
               <a:rPr lang="fr-FR" smtClean="0"/>
-              <a:t>15/05/2026</a:t>
+              <a:t>25/05/2026</a:t>
             </a:fld>
             <a:endParaRPr lang="fr-FR"/>
           </a:p>
@@ -2044,7 +2044,7 @@
           <a:p>
             <a:fld id="{017B969D-5DBB-4D98-A8ED-E39D79CDECF7}" type="datetimeFigureOut">
               <a:rPr lang="fr-FR" smtClean="0"/>
-              <a:t>15/05/2026</a:t>
+              <a:t>25/05/2026</a:t>
             </a:fld>
             <a:endParaRPr lang="fr-FR"/>
           </a:p>
@@ -2162,7 +2162,7 @@
           <a:p>
             <a:fld id="{017B969D-5DBB-4D98-A8ED-E39D79CDECF7}" type="datetimeFigureOut">
               <a:rPr lang="fr-FR" smtClean="0"/>
-              <a:t>15/05/2026</a:t>
+              <a:t>25/05/2026</a:t>
             </a:fld>
             <a:endParaRPr lang="fr-FR"/>
           </a:p>
@@ -2257,7 +2257,7 @@
           <a:p>
             <a:fld id="{017B969D-5DBB-4D98-A8ED-E39D79CDECF7}" type="datetimeFigureOut">
               <a:rPr lang="fr-FR" smtClean="0"/>
-              <a:t>15/05/2026</a:t>
+              <a:t>25/05/2026</a:t>
             </a:fld>
             <a:endParaRPr lang="fr-FR"/>
           </a:p>
@@ -2534,7 +2534,7 @@
           <a:p>
             <a:fld id="{017B969D-5DBB-4D98-A8ED-E39D79CDECF7}" type="datetimeFigureOut">
               <a:rPr lang="fr-FR" smtClean="0"/>
-              <a:t>15/05/2026</a:t>
+              <a:t>25/05/2026</a:t>
             </a:fld>
             <a:endParaRPr lang="fr-FR"/>
           </a:p>
@@ -2791,7 +2791,7 @@
           <a:p>
             <a:fld id="{017B969D-5DBB-4D98-A8ED-E39D79CDECF7}" type="datetimeFigureOut">
               <a:rPr lang="fr-FR" smtClean="0"/>
-              <a:t>15/05/2026</a:t>
+              <a:t>25/05/2026</a:t>
             </a:fld>
             <a:endParaRPr lang="fr-FR"/>
           </a:p>
@@ -3004,7 +3004,7 @@
           <a:p>
             <a:fld id="{017B969D-5DBB-4D98-A8ED-E39D79CDECF7}" type="datetimeFigureOut">
               <a:rPr lang="fr-FR" smtClean="0"/>
-              <a:t>15/05/2026</a:t>
+              <a:t>25/05/2026</a:t>
             </a:fld>
             <a:endParaRPr lang="fr-FR"/>
           </a:p>
@@ -4236,7 +4236,7 @@
         </p:nvSpPr>
         <p:spPr>
           <a:xfrm>
-            <a:off x="2621110" y="2721793"/>
+            <a:off x="2621110" y="2697613"/>
             <a:ext cx="1656369" cy="264240"/>
           </a:xfrm>
           <a:prstGeom prst="rect">
@@ -4274,7 +4274,7 @@
         </p:nvSpPr>
         <p:spPr>
           <a:xfrm>
-            <a:off x="2629545" y="3102529"/>
+            <a:off x="2629545" y="3028488"/>
             <a:ext cx="1682065" cy="264240"/>
           </a:xfrm>
           <a:prstGeom prst="rect">
@@ -4312,7 +4312,7 @@
         </p:nvSpPr>
         <p:spPr>
           <a:xfrm>
-            <a:off x="2621110" y="3485038"/>
+            <a:off x="2621110" y="3688238"/>
             <a:ext cx="1682065" cy="610061"/>
           </a:xfrm>
           <a:prstGeom prst="rect">
@@ -4637,7 +4637,7 @@
         </p:nvSpPr>
         <p:spPr>
           <a:xfrm>
-            <a:off x="2693141" y="3714307"/>
+            <a:off x="2693141" y="3917507"/>
             <a:ext cx="1512306" cy="274944"/>
           </a:xfrm>
           <a:prstGeom prst="rect">
@@ -5003,10 +5003,12 @@
         <p:spPr>
           <a:xfrm flipV="1">
             <a:off x="4205447" y="3606822"/>
-            <a:ext cx="774704" cy="244957"/>
-          </a:xfrm>
-          <a:prstGeom prst="straightConnector1">
-            <a:avLst/>
+            <a:ext cx="774704" cy="448157"/>
+          </a:xfrm>
+          <a:prstGeom prst="bentConnector3">
+            <a:avLst>
+              <a:gd name="adj1" fmla="val 50000"/>
+            </a:avLst>
           </a:prstGeom>
           <a:ln>
             <a:prstDash val="sysDash"/>
@@ -5064,6 +5066,65 @@
           </a:prstGeom>
         </p:spPr>
       </p:pic>
+      <p:sp>
+        <p:nvSpPr>
+          <p:cNvPr id="5" name="ZoneTexte 4">
+            <a:extLst>
+              <a:ext uri="{FF2B5EF4-FFF2-40B4-BE49-F238E27FC236}">
+                <a16:creationId xmlns:a16="http://schemas.microsoft.com/office/drawing/2014/main" id="{E4FEE4FC-DEC2-D3E9-BAD5-F20D5FF66777}"/>
+              </a:ext>
+            </a:extLst>
+          </p:cNvPr>
+          <p:cNvSpPr txBox="1"/>
+          <p:nvPr/>
+        </p:nvSpPr>
+        <p:spPr>
+          <a:xfrm>
+            <a:off x="2621110" y="3359363"/>
+            <a:ext cx="1682065" cy="262240"/>
+          </a:xfrm>
+          <a:prstGeom prst="rect">
+            <a:avLst/>
+          </a:prstGeom>
+          <a:blipFill>
+            <a:blip r:embed="rId4">
+              <a:extLst>
+                <a:ext uri="{BEBA8EAE-BF5A-486C-A8C5-ECC9F3942E4B}">
+                  <a14:imgProps xmlns:a14="http://schemas.microsoft.com/office/drawing/2010/main">
+                    <a14:imgLayer r:embed="rId5">
+                      <a14:imgEffect>
+                        <a14:artisticWatercolorSponge/>
+                      </a14:imgEffect>
+                      <a14:imgEffect>
+                        <a14:brightnessContrast bright="40000" contrast="-40000"/>
+                      </a14:imgEffect>
+                    </a14:imgLayer>
+                  </a14:imgProps>
+                </a:ext>
+              </a:extLst>
+            </a:blip>
+            <a:tile tx="0" ty="0" sx="100000" sy="100000" flip="none" algn="tl"/>
+          </a:blipFill>
+          <a:ln w="6350">
+            <a:solidFill>
+              <a:schemeClr val="tx1"/>
+            </a:solidFill>
+          </a:ln>
+        </p:spPr>
+        <p:txBody>
+          <a:bodyPr wrap="square" rtlCol="0">
+            <a:noAutofit/>
+          </a:bodyPr>
+          <a:lstStyle/>
+          <a:p>
+            <a:pPr algn="ctr"/>
+            <a:r>
+              <a:rPr lang="fr-FR" sz="1117" dirty="0"/>
+              <a:t>Espion</a:t>
+            </a:r>
+          </a:p>
+        </p:txBody>
+      </p:sp>
     </p:spTree>
     <p:extLst>
       <p:ext uri="{BB962C8B-B14F-4D97-AF65-F5344CB8AC3E}">

</xml_diff>

<commit_message>
Correction de la version avec nouveau second deck
</commit_message>
<xml_diff>
--- a/pictures/Memos/memo-fr.pptx
+++ b/pictures/Memos/memo-fr.pptx
@@ -4805,52 +4805,6 @@
       </p:pic>
       <p:pic>
         <p:nvPicPr>
-          <p:cNvPr id="282" name="Image 281">
-            <a:extLst>
-              <a:ext uri="{FF2B5EF4-FFF2-40B4-BE49-F238E27FC236}">
-                <a16:creationId xmlns:a16="http://schemas.microsoft.com/office/drawing/2014/main" id="{D2B5E59A-955D-6E37-70A8-EF428207DD59}"/>
-              </a:ext>
-            </a:extLst>
-          </p:cNvPr>
-          <p:cNvPicPr>
-            <a:picLocks noChangeAspect="1"/>
-          </p:cNvPicPr>
-          <p:nvPr/>
-        </p:nvPicPr>
-        <p:blipFill rotWithShape="1">
-          <a:blip r:embed="rId9">
-            <a:extLst>
-              <a:ext uri="{28A0092B-C50C-407E-A947-70E740481C1C}">
-                <a14:useLocalDpi xmlns:a14="http://schemas.microsoft.com/office/drawing/2010/main" val="0"/>
-              </a:ext>
-            </a:extLst>
-          </a:blip>
-          <a:srcRect l="35764" r="35779" b="24600"/>
-          <a:stretch>
-            <a:fillRect/>
-          </a:stretch>
-        </p:blipFill>
-        <p:spPr bwMode="auto">
-          <a:xfrm>
-            <a:off x="2425928" y="8880506"/>
-            <a:ext cx="4892835" cy="1451827"/>
-          </a:xfrm>
-          <a:prstGeom prst="rect">
-            <a:avLst/>
-          </a:prstGeom>
-          <a:noFill/>
-          <a:ln>
-            <a:noFill/>
-          </a:ln>
-          <a:extLst>
-            <a:ext uri="{53640926-AAD7-44D8-BBD7-CCE9431645EC}">
-              <a14:shadowObscured xmlns:a14="http://schemas.microsoft.com/office/drawing/2010/main"/>
-            </a:ext>
-          </a:extLst>
-        </p:spPr>
-      </p:pic>
-      <p:pic>
-        <p:nvPicPr>
           <p:cNvPr id="283" name="Image 282">
             <a:extLst>
               <a:ext uri="{FF2B5EF4-FFF2-40B4-BE49-F238E27FC236}">
@@ -4864,7 +4818,7 @@
           <p:nvPr/>
         </p:nvPicPr>
         <p:blipFill>
-          <a:blip r:embed="rId10">
+          <a:blip r:embed="rId9">
             <a:lum bright="70000" contrast="-70000"/>
             <a:extLst>
               <a:ext uri="{28A0092B-C50C-407E-A947-70E740481C1C}">
@@ -4906,7 +4860,7 @@
           <p:nvPr/>
         </p:nvPicPr>
         <p:blipFill>
-          <a:blip r:embed="rId10">
+          <a:blip r:embed="rId9">
             <a:lum bright="70000" contrast="-70000"/>
             <a:extLst>
               <a:ext uri="{28A0092B-C50C-407E-A947-70E740481C1C}">
@@ -5048,7 +5002,7 @@
           <a:blip>
             <a:extLst>
               <a:ext uri="{96DAC541-7B7A-43D3-8B79-37D633B846F1}">
-                <asvg:svgBlip xmlns:asvg="http://schemas.microsoft.com/office/drawing/2016/SVG/main" r:embed="rId11"/>
+                <asvg:svgBlip xmlns:asvg="http://schemas.microsoft.com/office/drawing/2016/SVG/main" r:embed="rId10"/>
               </a:ext>
             </a:extLst>
           </a:blip>
@@ -5125,6 +5079,52 @@
           </a:p>
         </p:txBody>
       </p:sp>
+      <p:pic>
+        <p:nvPicPr>
+          <p:cNvPr id="14" name="Image 13">
+            <a:extLst>
+              <a:ext uri="{FF2B5EF4-FFF2-40B4-BE49-F238E27FC236}">
+                <a16:creationId xmlns:a16="http://schemas.microsoft.com/office/drawing/2014/main" id="{1144B545-CC35-190B-52DA-97E13E34059D}"/>
+              </a:ext>
+            </a:extLst>
+          </p:cNvPr>
+          <p:cNvPicPr>
+            <a:picLocks noChangeAspect="1"/>
+          </p:cNvPicPr>
+          <p:nvPr/>
+        </p:nvPicPr>
+        <p:blipFill rotWithShape="1">
+          <a:blip r:embed="rId11">
+            <a:extLst>
+              <a:ext uri="{28A0092B-C50C-407E-A947-70E740481C1C}">
+                <a14:useLocalDpi xmlns:a14="http://schemas.microsoft.com/office/drawing/2010/main" val="0"/>
+              </a:ext>
+            </a:extLst>
+          </a:blip>
+          <a:srcRect l="35780" r="35811" b="24080"/>
+          <a:stretch>
+            <a:fillRect/>
+          </a:stretch>
+        </p:blipFill>
+        <p:spPr bwMode="auto">
+          <a:xfrm>
+            <a:off x="2143352" y="8910041"/>
+            <a:ext cx="5046038" cy="1507584"/>
+          </a:xfrm>
+          <a:prstGeom prst="rect">
+            <a:avLst/>
+          </a:prstGeom>
+          <a:noFill/>
+          <a:ln>
+            <a:noFill/>
+          </a:ln>
+          <a:extLst>
+            <a:ext uri="{53640926-AAD7-44D8-BBD7-CCE9431645EC}">
+              <a14:shadowObscured xmlns:a14="http://schemas.microsoft.com/office/drawing/2010/main"/>
+            </a:ext>
+          </a:extLst>
+        </p:spPr>
+      </p:pic>
     </p:spTree>
     <p:extLst>
       <p:ext uri="{BB962C8B-B14F-4D97-AF65-F5344CB8AC3E}">

</xml_diff>